<commit_message>
fix: preserve mixed-format dates from data dictionary
</commit_message>
<xml_diff>
--- a/deliverables/Quoter_Tech1a_diagrams.pptx
+++ b/deliverables/Quoter_Tech1a_diagrams.pptx
@@ -2,16 +2,16 @@
 <file path=ppt/presentation.xml><?xml version="1.0" encoding="utf-8"?>
 <p:presentation xmlns:p="http://schemas.openxmlformats.org/presentationml/2006/main">
   <p:sldMasterIdLst>
-    <p:sldMasterId xmlns:r="http://schemas.openxmlformats.org/officeDocument/2006/relationships" id="2147483648" r:id="R3473879b879f4ecb"/>
+    <p:sldMasterId xmlns:r="http://schemas.openxmlformats.org/officeDocument/2006/relationships" id="2147483648" r:id="R39a664391ade45e1"/>
   </p:sldMasterIdLst>
   <p:notesMasterIdLst>
-    <p:notesMasterId xmlns:r="http://schemas.openxmlformats.org/officeDocument/2006/relationships" r:id="Re97ca2c240fa46ab"/>
+    <p:notesMasterId xmlns:r="http://schemas.openxmlformats.org/officeDocument/2006/relationships" r:id="R9abb1d1ea8184e44"/>
   </p:notesMasterIdLst>
   <p:sldIdLst>
-    <p:sldId xmlns:r="http://schemas.openxmlformats.org/officeDocument/2006/relationships" id="256" r:id="Ra535ba0b56004fb8"/>
-    <p:sldId xmlns:r="http://schemas.openxmlformats.org/officeDocument/2006/relationships" id="257" r:id="Ra0ce3d4ff8624f2a"/>
-    <p:sldId xmlns:r="http://schemas.openxmlformats.org/officeDocument/2006/relationships" id="258" r:id="Rd5985924b7024992"/>
-    <p:sldId xmlns:r="http://schemas.openxmlformats.org/officeDocument/2006/relationships" id="259" r:id="R85e668caa6cd4387"/>
+    <p:sldId xmlns:r="http://schemas.openxmlformats.org/officeDocument/2006/relationships" id="256" r:id="R0510a7d79395485e"/>
+    <p:sldId xmlns:r="http://schemas.openxmlformats.org/officeDocument/2006/relationships" id="257" r:id="Rca22fff8c3c8422b"/>
+    <p:sldId xmlns:r="http://schemas.openxmlformats.org/officeDocument/2006/relationships" id="258" r:id="Rfde3b69964374224"/>
+    <p:sldId xmlns:r="http://schemas.openxmlformats.org/officeDocument/2006/relationships" id="259" r:id="R0b6484f56a814918"/>
   </p:sldIdLst>
   <p:sldSz cx="12192000" cy="6858000"/>
   <p:notesSz cx="6858000" cy="9144000"/>
@@ -788,7 +788,7 @@
   </p:cSld>
   <p:clrMap bg1="lt1" tx1="dk1" bg2="lt2" tx2="dk2" accent1="accent1" accent2="accent2" accent3="accent3" accent4="accent4" accent5="accent5" accent6="accent6" hlink="hlink" folHlink="folHlink"/>
   <p:sldLayoutIdLst>
-    <p:sldLayoutId xmlns:r="http://schemas.openxmlformats.org/officeDocument/2006/relationships" id="2147483649" r:id="Rf0efb52c0465419a"/>
+    <p:sldLayoutId xmlns:r="http://schemas.openxmlformats.org/officeDocument/2006/relationships" id="2147483649" r:id="R545b2d289d2943ea"/>
   </p:sldLayoutIdLst>
   <p:txStyles>
     <p:titleStyle>
@@ -1339,7 +1339,7 @@
           <p:cNvPr id="15" name="">
             <a:extLst xmlns:a="http://schemas.openxmlformats.org/drawingml/2006/main">
               <a:ext uri="{FF2B5EF4-FFF2-40B4-BE49-F238E27FC236}">
-                <a16:creationId xmlns:a16="http://schemas.microsoft.com/office/drawing/2014/main" id="{F42FD51B-F561-459D-BC28-02D63708EEB7}"/>
+                <a16:creationId xmlns:a16="http://schemas.microsoft.com/office/drawing/2014/main" id="{0B7F97B4-18A8-4A1A-BA5B-DDE47388E1F5}"/>
               </a:ext>
             </a:extLst>
           </p:cNvPr>
@@ -1397,7 +1397,7 @@
           <p:cNvPr id="2" name="">
             <a:extLst xmlns:a="http://schemas.openxmlformats.org/drawingml/2006/main">
               <a:ext uri="{FF2B5EF4-FFF2-40B4-BE49-F238E27FC236}">
-                <a16:creationId xmlns:a16="http://schemas.microsoft.com/office/drawing/2014/main" id="{B618B0F2-1FBC-47D6-B786-806912D7AC38}"/>
+                <a16:creationId xmlns:a16="http://schemas.microsoft.com/office/drawing/2014/main" id="{0DD66AD1-0D1F-47A7-947F-64CE4E26DB5F}"/>
               </a:ext>
             </a:extLst>
           </p:cNvPr>
@@ -1455,7 +1455,7 @@
           <p:cNvPr id="3" name="">
             <a:extLst xmlns:a="http://schemas.openxmlformats.org/drawingml/2006/main">
               <a:ext uri="{FF2B5EF4-FFF2-40B4-BE49-F238E27FC236}">
-                <a16:creationId xmlns:a16="http://schemas.microsoft.com/office/drawing/2014/main" id="{A8DD86A6-5A70-4441-9FD8-876450707959}"/>
+                <a16:creationId xmlns:a16="http://schemas.microsoft.com/office/drawing/2014/main" id="{CDDBCD8B-B450-4B24-89E7-EB243A766990}"/>
               </a:ext>
             </a:extLst>
           </p:cNvPr>
@@ -1513,7 +1513,7 @@
           <p:cNvPr id="4" name="">
             <a:extLst xmlns:a="http://schemas.openxmlformats.org/drawingml/2006/main">
               <a:ext uri="{FF2B5EF4-FFF2-40B4-BE49-F238E27FC236}">
-                <a16:creationId xmlns:a16="http://schemas.microsoft.com/office/drawing/2014/main" id="{985F3AA8-0D5F-4BC8-B3EB-2C98706C3EAC}"/>
+                <a16:creationId xmlns:a16="http://schemas.microsoft.com/office/drawing/2014/main" id="{03B95F73-3207-4BB9-8D46-B19AFA82495E}"/>
               </a:ext>
             </a:extLst>
           </p:cNvPr>
@@ -1575,7 +1575,7 @@
           <p:cNvPr id="5" name="">
             <a:extLst xmlns:a="http://schemas.openxmlformats.org/drawingml/2006/main">
               <a:ext uri="{FF2B5EF4-FFF2-40B4-BE49-F238E27FC236}">
-                <a16:creationId xmlns:a16="http://schemas.microsoft.com/office/drawing/2014/main" id="{FF567EDC-B38D-4BD2-9B00-54494F3B3592}"/>
+                <a16:creationId xmlns:a16="http://schemas.microsoft.com/office/drawing/2014/main" id="{BE95EAAC-AC1A-4166-A282-47F8933DA10E}"/>
               </a:ext>
             </a:extLst>
           </p:cNvPr>
@@ -1633,7 +1633,7 @@
           <p:cNvPr id="6" name="">
             <a:extLst xmlns:a="http://schemas.openxmlformats.org/drawingml/2006/main">
               <a:ext uri="{FF2B5EF4-FFF2-40B4-BE49-F238E27FC236}">
-                <a16:creationId xmlns:a16="http://schemas.microsoft.com/office/drawing/2014/main" id="{114BC4AC-633F-4383-83F5-6C5154021195}"/>
+                <a16:creationId xmlns:a16="http://schemas.microsoft.com/office/drawing/2014/main" id="{7E6D93D3-B830-4ABD-A7AE-7148379BB08F}"/>
               </a:ext>
             </a:extLst>
           </p:cNvPr>
@@ -1691,7 +1691,7 @@
           <p:cNvPr id="7" name="">
             <a:extLst xmlns:a="http://schemas.openxmlformats.org/drawingml/2006/main">
               <a:ext uri="{FF2B5EF4-FFF2-40B4-BE49-F238E27FC236}">
-                <a16:creationId xmlns:a16="http://schemas.microsoft.com/office/drawing/2014/main" id="{7ACA8E0B-B5A0-4241-A529-8F3AA8ACDAD6}"/>
+                <a16:creationId xmlns:a16="http://schemas.microsoft.com/office/drawing/2014/main" id="{9C196733-CBE7-4779-A525-11FFB00CD471}"/>
               </a:ext>
             </a:extLst>
           </p:cNvPr>
@@ -1749,7 +1749,7 @@
           <p:cNvPr id="8" name="">
             <a:extLst xmlns:a="http://schemas.openxmlformats.org/drawingml/2006/main">
               <a:ext uri="{FF2B5EF4-FFF2-40B4-BE49-F238E27FC236}">
-                <a16:creationId xmlns:a16="http://schemas.microsoft.com/office/drawing/2014/main" id="{321250AE-3618-434A-82C7-61734D23007E}"/>
+                <a16:creationId xmlns:a16="http://schemas.microsoft.com/office/drawing/2014/main" id="{0DB6BF1F-5207-43EF-8DCA-36C5AB7ECED5}"/>
               </a:ext>
             </a:extLst>
           </p:cNvPr>
@@ -1807,7 +1807,7 @@
           <p:cNvPr id="9" name="">
             <a:extLst xmlns:a="http://schemas.openxmlformats.org/drawingml/2006/main">
               <a:ext uri="{FF2B5EF4-FFF2-40B4-BE49-F238E27FC236}">
-                <a16:creationId xmlns:a16="http://schemas.microsoft.com/office/drawing/2014/main" id="{54E90E90-C5AE-43FB-B555-7214AB2BF5C6}"/>
+                <a16:creationId xmlns:a16="http://schemas.microsoft.com/office/drawing/2014/main" id="{799C48A1-A4AC-46F8-ADDB-BDC4B3C4BCAE}"/>
               </a:ext>
             </a:extLst>
           </p:cNvPr>
@@ -1865,7 +1865,7 @@
           <p:cNvPr id="10" name="">
             <a:extLst xmlns:a="http://schemas.openxmlformats.org/drawingml/2006/main">
               <a:ext uri="{FF2B5EF4-FFF2-40B4-BE49-F238E27FC236}">
-                <a16:creationId xmlns:a16="http://schemas.microsoft.com/office/drawing/2014/main" id="{FF8AE05A-0309-472C-A505-DFCC5F3AAC84}"/>
+                <a16:creationId xmlns:a16="http://schemas.microsoft.com/office/drawing/2014/main" id="{306E0F18-67C1-46E2-BF52-37350BE1B6F0}"/>
               </a:ext>
             </a:extLst>
           </p:cNvPr>
@@ -1923,7 +1923,7 @@
           <p:cNvPr id="11" name="">
             <a:extLst xmlns:a="http://schemas.openxmlformats.org/drawingml/2006/main">
               <a:ext uri="{FF2B5EF4-FFF2-40B4-BE49-F238E27FC236}">
-                <a16:creationId xmlns:a16="http://schemas.microsoft.com/office/drawing/2014/main" id="{E40CA059-AF0B-4B43-A0C1-A1F5E410FD51}"/>
+                <a16:creationId xmlns:a16="http://schemas.microsoft.com/office/drawing/2014/main" id="{7DC6F7BD-6521-4E10-87BD-A0DB5824F96B}"/>
               </a:ext>
             </a:extLst>
           </p:cNvPr>
@@ -1971,7 +1971,7 @@
                 <a:ea typeface="Arial"/>
                 <a:cs typeface="Arial"/>
               </a:rPr>
-              <a:t>3,549</a:t>
+              <a:t>3,635</a:t>
             </a:r>
           </a:p>
         </p:txBody>
@@ -1981,7 +1981,7 @@
           <p:cNvPr id="12" name="">
             <a:extLst xmlns:a="http://schemas.openxmlformats.org/drawingml/2006/main">
               <a:ext uri="{FF2B5EF4-FFF2-40B4-BE49-F238E27FC236}">
-                <a16:creationId xmlns:a16="http://schemas.microsoft.com/office/drawing/2014/main" id="{06AEEDBF-92E4-4783-B5EE-5CF0DA9B81F1}"/>
+                <a16:creationId xmlns:a16="http://schemas.microsoft.com/office/drawing/2014/main" id="{6CFF6585-C4D9-4929-9410-D2E404768253}"/>
               </a:ext>
             </a:extLst>
           </p:cNvPr>
@@ -2039,7 +2039,7 @@
           <p:cNvPr id="13" name="">
             <a:extLst xmlns:a="http://schemas.openxmlformats.org/drawingml/2006/main">
               <a:ext uri="{FF2B5EF4-FFF2-40B4-BE49-F238E27FC236}">
-                <a16:creationId xmlns:a16="http://schemas.microsoft.com/office/drawing/2014/main" id="{14A6851F-C9D0-4122-8244-11070C9D6096}"/>
+                <a16:creationId xmlns:a16="http://schemas.microsoft.com/office/drawing/2014/main" id="{67E8C538-5210-4C6F-8999-411B26995F90}"/>
               </a:ext>
             </a:extLst>
           </p:cNvPr>
@@ -2097,7 +2097,7 @@
           <p:cNvPr id="14" name="">
             <a:extLst xmlns:a="http://schemas.openxmlformats.org/drawingml/2006/main">
               <a:ext uri="{FF2B5EF4-FFF2-40B4-BE49-F238E27FC236}">
-                <a16:creationId xmlns:a16="http://schemas.microsoft.com/office/drawing/2014/main" id="{66140436-80CB-4DE9-8873-8D016E749D21}"/>
+                <a16:creationId xmlns:a16="http://schemas.microsoft.com/office/drawing/2014/main" id="{321E37C2-A4FE-4E11-8E9E-E584B17C791C}"/>
               </a:ext>
             </a:extLst>
           </p:cNvPr>
@@ -2153,7 +2153,7 @@
     </p:spTree>
     <p:extLst>
       <p:ext uri="{BB962C8B-B14F-4D97-AF65-F5344CB8AC3E}">
-        <p14:creationId xmlns:p14="http://schemas.microsoft.com/office/powerpoint/2010/main" val="909803318"/>
+        <p14:creationId xmlns:p14="http://schemas.microsoft.com/office/powerpoint/2010/main" val="270278910"/>
       </p:ext>
     </p:extLst>
   </p:cSld>
@@ -2184,7 +2184,7 @@
           <p:cNvPr id="36" name="">
             <a:extLst xmlns:a="http://schemas.openxmlformats.org/drawingml/2006/main">
               <a:ext uri="{FF2B5EF4-FFF2-40B4-BE49-F238E27FC236}">
-                <a16:creationId xmlns:a16="http://schemas.microsoft.com/office/drawing/2014/main" id="{A5D8528E-EB67-43F4-823C-95A4045E8F1C}"/>
+                <a16:creationId xmlns:a16="http://schemas.microsoft.com/office/drawing/2014/main" id="{7B8185D9-AC1C-48C5-A6D1-AB4876465EAA}"/>
               </a:ext>
             </a:extLst>
           </p:cNvPr>
@@ -2242,7 +2242,7 @@
           <p:cNvPr id="2" name="">
             <a:extLst xmlns:a="http://schemas.openxmlformats.org/drawingml/2006/main">
               <a:ext uri="{FF2B5EF4-FFF2-40B4-BE49-F238E27FC236}">
-                <a16:creationId xmlns:a16="http://schemas.microsoft.com/office/drawing/2014/main" id="{FB9F8BA6-820E-4838-9D32-606F1222BD02}"/>
+                <a16:creationId xmlns:a16="http://schemas.microsoft.com/office/drawing/2014/main" id="{EFAD5364-DE0B-433A-83DF-748FD7AE253F}"/>
               </a:ext>
             </a:extLst>
           </p:cNvPr>
@@ -2300,7 +2300,7 @@
           <p:cNvPr id="3" name="">
             <a:extLst xmlns:a="http://schemas.openxmlformats.org/drawingml/2006/main">
               <a:ext uri="{FF2B5EF4-FFF2-40B4-BE49-F238E27FC236}">
-                <a16:creationId xmlns:a16="http://schemas.microsoft.com/office/drawing/2014/main" id="{B40565C1-B7F8-4B65-87F5-903710294055}"/>
+                <a16:creationId xmlns:a16="http://schemas.microsoft.com/office/drawing/2014/main" id="{7E19CE99-6662-4926-9632-E20AB289CE48}"/>
               </a:ext>
             </a:extLst>
           </p:cNvPr>
@@ -2358,7 +2358,7 @@
           <p:cNvPr id="4" name="">
             <a:extLst xmlns:a="http://schemas.openxmlformats.org/drawingml/2006/main">
               <a:ext uri="{FF2B5EF4-FFF2-40B4-BE49-F238E27FC236}">
-                <a16:creationId xmlns:a16="http://schemas.microsoft.com/office/drawing/2014/main" id="{A8F29471-6A11-4807-86D4-79282C88691D}"/>
+                <a16:creationId xmlns:a16="http://schemas.microsoft.com/office/drawing/2014/main" id="{6220F93D-E939-424E-8E11-81073E1C924E}"/>
               </a:ext>
             </a:extLst>
           </p:cNvPr>
@@ -2391,7 +2391,7 @@
           <p:cNvPr id="5" name="">
             <a:extLst xmlns:a="http://schemas.openxmlformats.org/drawingml/2006/main">
               <a:ext uri="{FF2B5EF4-FFF2-40B4-BE49-F238E27FC236}">
-                <a16:creationId xmlns:a16="http://schemas.microsoft.com/office/drawing/2014/main" id="{ADF0F743-1966-43DC-9560-AA761C1A3C05}"/>
+                <a16:creationId xmlns:a16="http://schemas.microsoft.com/office/drawing/2014/main" id="{C2E7D8D6-AC7C-4F9A-9FDE-74D1A00EB16A}"/>
               </a:ext>
             </a:extLst>
           </p:cNvPr>
@@ -2435,7 +2435,7 @@
           <p:cNvPr id="6" name="">
             <a:extLst xmlns:a="http://schemas.openxmlformats.org/drawingml/2006/main">
               <a:ext uri="{FF2B5EF4-FFF2-40B4-BE49-F238E27FC236}">
-                <a16:creationId xmlns:a16="http://schemas.microsoft.com/office/drawing/2014/main" id="{10DC0372-873C-41F2-AEDC-A3CA9961FBA5}"/>
+                <a16:creationId xmlns:a16="http://schemas.microsoft.com/office/drawing/2014/main" id="{55899DDE-10CC-423C-99C5-5047D6E94009}"/>
               </a:ext>
             </a:extLst>
           </p:cNvPr>
@@ -2493,7 +2493,7 @@
           <p:cNvPr id="7" name="">
             <a:extLst xmlns:a="http://schemas.openxmlformats.org/drawingml/2006/main">
               <a:ext uri="{FF2B5EF4-FFF2-40B4-BE49-F238E27FC236}">
-                <a16:creationId xmlns:a16="http://schemas.microsoft.com/office/drawing/2014/main" id="{082D500D-0D7F-4D84-A11E-0AB9FB6530C8}"/>
+                <a16:creationId xmlns:a16="http://schemas.microsoft.com/office/drawing/2014/main" id="{13E4E462-39C7-4CC9-8617-E99AEBDE8C8F}"/>
               </a:ext>
             </a:extLst>
           </p:cNvPr>
@@ -2537,7 +2537,7 @@
           <p:cNvPr id="8" name="">
             <a:extLst xmlns:a="http://schemas.openxmlformats.org/drawingml/2006/main">
               <a:ext uri="{FF2B5EF4-FFF2-40B4-BE49-F238E27FC236}">
-                <a16:creationId xmlns:a16="http://schemas.microsoft.com/office/drawing/2014/main" id="{6D22E2CA-CDFE-4A5B-A353-5DE9E7557A83}"/>
+                <a16:creationId xmlns:a16="http://schemas.microsoft.com/office/drawing/2014/main" id="{DCD26103-2794-4E83-B1F0-CDE160065072}"/>
               </a:ext>
             </a:extLst>
           </p:cNvPr>
@@ -2595,7 +2595,7 @@
           <p:cNvPr id="9" name="">
             <a:extLst xmlns:a="http://schemas.openxmlformats.org/drawingml/2006/main">
               <a:ext uri="{FF2B5EF4-FFF2-40B4-BE49-F238E27FC236}">
-                <a16:creationId xmlns:a16="http://schemas.microsoft.com/office/drawing/2014/main" id="{32740025-6293-446A-8792-26D5EFC55977}"/>
+                <a16:creationId xmlns:a16="http://schemas.microsoft.com/office/drawing/2014/main" id="{124BDC64-7E2B-431A-988E-6D95346AD976}"/>
               </a:ext>
             </a:extLst>
           </p:cNvPr>
@@ -2639,7 +2639,7 @@
           <p:cNvPr id="10" name="">
             <a:extLst xmlns:a="http://schemas.openxmlformats.org/drawingml/2006/main">
               <a:ext uri="{FF2B5EF4-FFF2-40B4-BE49-F238E27FC236}">
-                <a16:creationId xmlns:a16="http://schemas.microsoft.com/office/drawing/2014/main" id="{0D72CAD2-CA94-4EFF-9643-F23B2A06A4BD}"/>
+                <a16:creationId xmlns:a16="http://schemas.microsoft.com/office/drawing/2014/main" id="{48EF88E2-C701-4954-B980-EE1B88C6B3DB}"/>
               </a:ext>
             </a:extLst>
           </p:cNvPr>
@@ -2697,7 +2697,7 @@
           <p:cNvPr id="11" name="">
             <a:extLst xmlns:a="http://schemas.openxmlformats.org/drawingml/2006/main">
               <a:ext uri="{FF2B5EF4-FFF2-40B4-BE49-F238E27FC236}">
-                <a16:creationId xmlns:a16="http://schemas.microsoft.com/office/drawing/2014/main" id="{588C4629-8F61-46EF-A51D-A84E39795FBD}"/>
+                <a16:creationId xmlns:a16="http://schemas.microsoft.com/office/drawing/2014/main" id="{CE5FEBF2-CC3E-4C86-AD75-F4E4370229A2}"/>
               </a:ext>
             </a:extLst>
           </p:cNvPr>
@@ -2759,7 +2759,7 @@
           <p:cNvPr id="12" name="">
             <a:extLst xmlns:a="http://schemas.openxmlformats.org/drawingml/2006/main">
               <a:ext uri="{FF2B5EF4-FFF2-40B4-BE49-F238E27FC236}">
-                <a16:creationId xmlns:a16="http://schemas.microsoft.com/office/drawing/2014/main" id="{97E66D8F-1E0C-47E5-A785-0EE99226A2A7}"/>
+                <a16:creationId xmlns:a16="http://schemas.microsoft.com/office/drawing/2014/main" id="{3F7389A5-67FC-4059-9E51-886D570FC759}"/>
               </a:ext>
             </a:extLst>
           </p:cNvPr>
@@ -2821,7 +2821,7 @@
           <p:cNvPr id="13" name="">
             <a:extLst xmlns:a="http://schemas.openxmlformats.org/drawingml/2006/main">
               <a:ext uri="{FF2B5EF4-FFF2-40B4-BE49-F238E27FC236}">
-                <a16:creationId xmlns:a16="http://schemas.microsoft.com/office/drawing/2014/main" id="{CE94180E-AA89-4E85-8208-74008ADED8E9}"/>
+                <a16:creationId xmlns:a16="http://schemas.microsoft.com/office/drawing/2014/main" id="{41B016A5-CA81-4B55-9AD9-0E8FF610D0E5}"/>
               </a:ext>
             </a:extLst>
           </p:cNvPr>
@@ -2883,7 +2883,7 @@
           <p:cNvPr id="14" name="">
             <a:extLst xmlns:a="http://schemas.openxmlformats.org/drawingml/2006/main">
               <a:ext uri="{FF2B5EF4-FFF2-40B4-BE49-F238E27FC236}">
-                <a16:creationId xmlns:a16="http://schemas.microsoft.com/office/drawing/2014/main" id="{C57DC1D0-3924-4886-9E35-9901AD73D224}"/>
+                <a16:creationId xmlns:a16="http://schemas.microsoft.com/office/drawing/2014/main" id="{44C55A4E-EB24-4EFC-BB34-1B42F2195C70}"/>
               </a:ext>
             </a:extLst>
           </p:cNvPr>
@@ -2945,7 +2945,7 @@
           <p:cNvPr id="15" name="">
             <a:extLst xmlns:a="http://schemas.openxmlformats.org/drawingml/2006/main">
               <a:ext uri="{FF2B5EF4-FFF2-40B4-BE49-F238E27FC236}">
-                <a16:creationId xmlns:a16="http://schemas.microsoft.com/office/drawing/2014/main" id="{A4467729-CF94-4A41-9428-80648F0BC39C}"/>
+                <a16:creationId xmlns:a16="http://schemas.microsoft.com/office/drawing/2014/main" id="{E5B10160-8C60-41CD-8160-C6213C03FE43}"/>
               </a:ext>
             </a:extLst>
           </p:cNvPr>
@@ -3007,7 +3007,7 @@
           <p:cNvPr id="16" name="">
             <a:extLst xmlns:a="http://schemas.openxmlformats.org/drawingml/2006/main">
               <a:ext uri="{FF2B5EF4-FFF2-40B4-BE49-F238E27FC236}">
-                <a16:creationId xmlns:a16="http://schemas.microsoft.com/office/drawing/2014/main" id="{E7E631ED-1C5C-43AA-B1F9-7E16B9F77591}"/>
+                <a16:creationId xmlns:a16="http://schemas.microsoft.com/office/drawing/2014/main" id="{AC28E0E7-55ED-4B00-B32A-92E75063B658}"/>
               </a:ext>
             </a:extLst>
           </p:cNvPr>
@@ -3069,7 +3069,7 @@
           <p:cNvPr id="17" name="">
             <a:extLst xmlns:a="http://schemas.openxmlformats.org/drawingml/2006/main">
               <a:ext uri="{FF2B5EF4-FFF2-40B4-BE49-F238E27FC236}">
-                <a16:creationId xmlns:a16="http://schemas.microsoft.com/office/drawing/2014/main" id="{EB9F3A40-702C-48F9-8E01-92F8E8D9C09B}"/>
+                <a16:creationId xmlns:a16="http://schemas.microsoft.com/office/drawing/2014/main" id="{36B4BEB3-5A01-42AD-B5BA-5E4104E25F39}"/>
               </a:ext>
             </a:extLst>
           </p:cNvPr>
@@ -3131,7 +3131,7 @@
           <p:cNvPr id="18" name="">
             <a:extLst xmlns:a="http://schemas.openxmlformats.org/drawingml/2006/main">
               <a:ext uri="{FF2B5EF4-FFF2-40B4-BE49-F238E27FC236}">
-                <a16:creationId xmlns:a16="http://schemas.microsoft.com/office/drawing/2014/main" id="{44583640-B66D-42E6-8D19-9E9BD59C855A}"/>
+                <a16:creationId xmlns:a16="http://schemas.microsoft.com/office/drawing/2014/main" id="{0525D092-9883-4C5C-BE6F-5FFD1EE6374C}"/>
               </a:ext>
             </a:extLst>
           </p:cNvPr>
@@ -3193,7 +3193,7 @@
           <p:cNvPr id="19" name="">
             <a:extLst xmlns:a="http://schemas.openxmlformats.org/drawingml/2006/main">
               <a:ext uri="{FF2B5EF4-FFF2-40B4-BE49-F238E27FC236}">
-                <a16:creationId xmlns:a16="http://schemas.microsoft.com/office/drawing/2014/main" id="{C88C0B0E-49B8-4476-BF87-2AE48C09E565}"/>
+                <a16:creationId xmlns:a16="http://schemas.microsoft.com/office/drawing/2014/main" id="{3E41D59F-9FF1-4C6A-B956-3308E0217433}"/>
               </a:ext>
             </a:extLst>
           </p:cNvPr>
@@ -3255,7 +3255,7 @@
           <p:cNvPr id="20" name="">
             <a:extLst xmlns:a="http://schemas.openxmlformats.org/drawingml/2006/main">
               <a:ext uri="{FF2B5EF4-FFF2-40B4-BE49-F238E27FC236}">
-                <a16:creationId xmlns:a16="http://schemas.microsoft.com/office/drawing/2014/main" id="{A8E5202F-5E90-4E97-AC92-F6FC7A4F4931}"/>
+                <a16:creationId xmlns:a16="http://schemas.microsoft.com/office/drawing/2014/main" id="{8E9943B3-4FDD-4D34-8B1C-BC9EF7DCD413}"/>
               </a:ext>
             </a:extLst>
           </p:cNvPr>
@@ -3317,7 +3317,7 @@
           <p:cNvPr id="21" name="">
             <a:extLst xmlns:a="http://schemas.openxmlformats.org/drawingml/2006/main">
               <a:ext uri="{FF2B5EF4-FFF2-40B4-BE49-F238E27FC236}">
-                <a16:creationId xmlns:a16="http://schemas.microsoft.com/office/drawing/2014/main" id="{E6BE7658-9DFD-4B97-BDEC-99B0B531114E}"/>
+                <a16:creationId xmlns:a16="http://schemas.microsoft.com/office/drawing/2014/main" id="{504A096A-E601-4B31-A8EE-8B33B241811F}"/>
               </a:ext>
             </a:extLst>
           </p:cNvPr>
@@ -3664,7 +3664,7 @@
           <p:cNvPr id="32" name="">
             <a:extLst xmlns:a="http://schemas.openxmlformats.org/drawingml/2006/main">
               <a:ext uri="{FF2B5EF4-FFF2-40B4-BE49-F238E27FC236}">
-                <a16:creationId xmlns:a16="http://schemas.microsoft.com/office/drawing/2014/main" id="{E7BEA019-24DD-4AA1-AC2C-C7213262A5AA}"/>
+                <a16:creationId xmlns:a16="http://schemas.microsoft.com/office/drawing/2014/main" id="{81DF5242-19BD-4376-B470-693453F6EC19}"/>
               </a:ext>
             </a:extLst>
           </p:cNvPr>
@@ -3722,7 +3722,7 @@
           <p:cNvPr id="33" name="">
             <a:extLst xmlns:a="http://schemas.openxmlformats.org/drawingml/2006/main">
               <a:ext uri="{FF2B5EF4-FFF2-40B4-BE49-F238E27FC236}">
-                <a16:creationId xmlns:a16="http://schemas.microsoft.com/office/drawing/2014/main" id="{2B4E7837-2A70-4B03-B7B9-52E2C16A09A2}"/>
+                <a16:creationId xmlns:a16="http://schemas.microsoft.com/office/drawing/2014/main" id="{08B288DF-3744-46F3-B3A5-C0C57607118F}"/>
               </a:ext>
             </a:extLst>
           </p:cNvPr>
@@ -3780,7 +3780,7 @@
           <p:cNvPr id="34" name="">
             <a:extLst xmlns:a="http://schemas.openxmlformats.org/drawingml/2006/main">
               <a:ext uri="{FF2B5EF4-FFF2-40B4-BE49-F238E27FC236}">
-                <a16:creationId xmlns:a16="http://schemas.microsoft.com/office/drawing/2014/main" id="{87243F8F-4DB3-4BA4-A3F9-413BB142F24A}"/>
+                <a16:creationId xmlns:a16="http://schemas.microsoft.com/office/drawing/2014/main" id="{8C614A65-9C3D-419D-8401-2A1DE791945C}"/>
               </a:ext>
             </a:extLst>
           </p:cNvPr>
@@ -3838,7 +3838,7 @@
           <p:cNvPr id="35" name="">
             <a:extLst xmlns:a="http://schemas.openxmlformats.org/drawingml/2006/main">
               <a:ext uri="{FF2B5EF4-FFF2-40B4-BE49-F238E27FC236}">
-                <a16:creationId xmlns:a16="http://schemas.microsoft.com/office/drawing/2014/main" id="{BF0A8FF7-0AEA-454A-86FC-657DE2AB383D}"/>
+                <a16:creationId xmlns:a16="http://schemas.microsoft.com/office/drawing/2014/main" id="{FBE59BDC-6BC9-4EC5-9353-A3CDD6097775}"/>
               </a:ext>
             </a:extLst>
           </p:cNvPr>
@@ -3894,7 +3894,7 @@
     </p:spTree>
     <p:extLst>
       <p:ext uri="{BB962C8B-B14F-4D97-AF65-F5344CB8AC3E}">
-        <p14:creationId xmlns:p14="http://schemas.microsoft.com/office/powerpoint/2010/main" val="1175751507"/>
+        <p14:creationId xmlns:p14="http://schemas.microsoft.com/office/powerpoint/2010/main" val="826314934"/>
       </p:ext>
     </p:extLst>
   </p:cSld>
@@ -3925,7 +3925,7 @@
           <p:cNvPr id="30" name="">
             <a:extLst xmlns:a="http://schemas.openxmlformats.org/drawingml/2006/main">
               <a:ext uri="{FF2B5EF4-FFF2-40B4-BE49-F238E27FC236}">
-                <a16:creationId xmlns:a16="http://schemas.microsoft.com/office/drawing/2014/main" id="{8B1B9F67-27A5-45AD-BA18-9FFBD5F8E1CA}"/>
+                <a16:creationId xmlns:a16="http://schemas.microsoft.com/office/drawing/2014/main" id="{0C1C21F3-A519-44AE-8871-20721409BFB0}"/>
               </a:ext>
             </a:extLst>
           </p:cNvPr>
@@ -3983,7 +3983,7 @@
           <p:cNvPr id="2" name="">
             <a:extLst xmlns:a="http://schemas.openxmlformats.org/drawingml/2006/main">
               <a:ext uri="{FF2B5EF4-FFF2-40B4-BE49-F238E27FC236}">
-                <a16:creationId xmlns:a16="http://schemas.microsoft.com/office/drawing/2014/main" id="{CB54CC68-495D-4A47-A152-EA3A96ABED2C}"/>
+                <a16:creationId xmlns:a16="http://schemas.microsoft.com/office/drawing/2014/main" id="{A2FE71EE-AA85-48FA-BB15-855731FCBB51}"/>
               </a:ext>
             </a:extLst>
           </p:cNvPr>
@@ -4041,7 +4041,7 @@
           <p:cNvPr id="3" name="">
             <a:extLst xmlns:a="http://schemas.openxmlformats.org/drawingml/2006/main">
               <a:ext uri="{FF2B5EF4-FFF2-40B4-BE49-F238E27FC236}">
-                <a16:creationId xmlns:a16="http://schemas.microsoft.com/office/drawing/2014/main" id="{7C7B753A-F6D6-4409-95C0-9BE5A654074A}"/>
+                <a16:creationId xmlns:a16="http://schemas.microsoft.com/office/drawing/2014/main" id="{AB7ABEE6-7669-49D2-8A7D-419864C86B82}"/>
               </a:ext>
             </a:extLst>
           </p:cNvPr>
@@ -4099,7 +4099,7 @@
           <p:cNvPr id="4" name="">
             <a:extLst xmlns:a="http://schemas.openxmlformats.org/drawingml/2006/main">
               <a:ext uri="{FF2B5EF4-FFF2-40B4-BE49-F238E27FC236}">
-                <a16:creationId xmlns:a16="http://schemas.microsoft.com/office/drawing/2014/main" id="{764257DB-70AA-444F-9D01-CD737509B9B7}"/>
+                <a16:creationId xmlns:a16="http://schemas.microsoft.com/office/drawing/2014/main" id="{0ADDC53B-192D-4080-ACFA-1F5FB1086935}"/>
               </a:ext>
             </a:extLst>
           </p:cNvPr>
@@ -4132,7 +4132,7 @@
           <p:cNvPr id="5" name="">
             <a:extLst xmlns:a="http://schemas.openxmlformats.org/drawingml/2006/main">
               <a:ext uri="{FF2B5EF4-FFF2-40B4-BE49-F238E27FC236}">
-                <a16:creationId xmlns:a16="http://schemas.microsoft.com/office/drawing/2014/main" id="{263D8554-EBCD-4BF2-BFA3-D5F8D7DE73B3}"/>
+                <a16:creationId xmlns:a16="http://schemas.microsoft.com/office/drawing/2014/main" id="{5540D6C7-33C7-4964-91C1-4DC9153E1B0F}"/>
               </a:ext>
             </a:extLst>
           </p:cNvPr>
@@ -4217,7 +4217,7 @@
           <p:cNvPr id="6" name="">
             <a:extLst xmlns:a="http://schemas.openxmlformats.org/drawingml/2006/main">
               <a:ext uri="{FF2B5EF4-FFF2-40B4-BE49-F238E27FC236}">
-                <a16:creationId xmlns:a16="http://schemas.microsoft.com/office/drawing/2014/main" id="{33A15247-3DAC-4511-B51A-2552C41816D7}"/>
+                <a16:creationId xmlns:a16="http://schemas.microsoft.com/office/drawing/2014/main" id="{7F3701B9-5F51-459C-84C0-31015ABD72B2}"/>
               </a:ext>
             </a:extLst>
           </p:cNvPr>
@@ -4279,7 +4279,7 @@
           <p:cNvPr id="7" name="">
             <a:extLst xmlns:a="http://schemas.openxmlformats.org/drawingml/2006/main">
               <a:ext uri="{FF2B5EF4-FFF2-40B4-BE49-F238E27FC236}">
-                <a16:creationId xmlns:a16="http://schemas.microsoft.com/office/drawing/2014/main" id="{EE8BE60F-7E75-459B-8F47-D6D9321A69BE}"/>
+                <a16:creationId xmlns:a16="http://schemas.microsoft.com/office/drawing/2014/main" id="{67C886C9-8C68-4A0A-91F7-E5DCD580FF5B}"/>
               </a:ext>
             </a:extLst>
           </p:cNvPr>
@@ -4364,7 +4364,7 @@
           <p:cNvPr id="8" name="">
             <a:extLst xmlns:a="http://schemas.openxmlformats.org/drawingml/2006/main">
               <a:ext uri="{FF2B5EF4-FFF2-40B4-BE49-F238E27FC236}">
-                <a16:creationId xmlns:a16="http://schemas.microsoft.com/office/drawing/2014/main" id="{A582CA75-CDE2-4465-BAFA-B9EBEB3A70E4}"/>
+                <a16:creationId xmlns:a16="http://schemas.microsoft.com/office/drawing/2014/main" id="{1C853F78-D81E-4497-9873-BD8E6EE307D4}"/>
               </a:ext>
             </a:extLst>
           </p:cNvPr>
@@ -4426,7 +4426,7 @@
           <p:cNvPr id="9" name="">
             <a:extLst xmlns:a="http://schemas.openxmlformats.org/drawingml/2006/main">
               <a:ext uri="{FF2B5EF4-FFF2-40B4-BE49-F238E27FC236}">
-                <a16:creationId xmlns:a16="http://schemas.microsoft.com/office/drawing/2014/main" id="{E03C199C-3854-422B-97F6-2829B3B12D2F}"/>
+                <a16:creationId xmlns:a16="http://schemas.microsoft.com/office/drawing/2014/main" id="{076ADEA8-13E1-48D7-BE81-BE66DACDAFA3}"/>
               </a:ext>
             </a:extLst>
           </p:cNvPr>
@@ -4511,7 +4511,7 @@
           <p:cNvPr id="10" name="">
             <a:extLst xmlns:a="http://schemas.openxmlformats.org/drawingml/2006/main">
               <a:ext uri="{FF2B5EF4-FFF2-40B4-BE49-F238E27FC236}">
-                <a16:creationId xmlns:a16="http://schemas.microsoft.com/office/drawing/2014/main" id="{B67EF83C-22AA-4AF3-84F7-F20FBAFA7E25}"/>
+                <a16:creationId xmlns:a16="http://schemas.microsoft.com/office/drawing/2014/main" id="{6B5992F5-E5FE-43F8-9C22-4600ADE878F9}"/>
               </a:ext>
             </a:extLst>
           </p:cNvPr>
@@ -4596,7 +4596,7 @@
           <p:cNvPr id="11" name="">
             <a:extLst xmlns:a="http://schemas.openxmlformats.org/drawingml/2006/main">
               <a:ext uri="{FF2B5EF4-FFF2-40B4-BE49-F238E27FC236}">
-                <a16:creationId xmlns:a16="http://schemas.microsoft.com/office/drawing/2014/main" id="{7A21118B-924B-4D63-A1E8-A2816BA32B01}"/>
+                <a16:creationId xmlns:a16="http://schemas.microsoft.com/office/drawing/2014/main" id="{011AD9D3-4B20-420F-BA45-EBB7E72EEA1D}"/>
               </a:ext>
             </a:extLst>
           </p:cNvPr>
@@ -4658,7 +4658,7 @@
           <p:cNvPr id="12" name="">
             <a:extLst xmlns:a="http://schemas.openxmlformats.org/drawingml/2006/main">
               <a:ext uri="{FF2B5EF4-FFF2-40B4-BE49-F238E27FC236}">
-                <a16:creationId xmlns:a16="http://schemas.microsoft.com/office/drawing/2014/main" id="{563CCCB8-E0D8-47D5-B004-597EEF8A6AEE}"/>
+                <a16:creationId xmlns:a16="http://schemas.microsoft.com/office/drawing/2014/main" id="{57C7AC57-1FC7-497F-90C1-7ED84912E4B8}"/>
               </a:ext>
             </a:extLst>
           </p:cNvPr>
@@ -4720,7 +4720,7 @@
           <p:cNvPr id="13" name="">
             <a:extLst xmlns:a="http://schemas.openxmlformats.org/drawingml/2006/main">
               <a:ext uri="{FF2B5EF4-FFF2-40B4-BE49-F238E27FC236}">
-                <a16:creationId xmlns:a16="http://schemas.microsoft.com/office/drawing/2014/main" id="{582D03DE-4F13-4CDA-8CA7-2345F4B93875}"/>
+                <a16:creationId xmlns:a16="http://schemas.microsoft.com/office/drawing/2014/main" id="{71B5CCBE-2A27-45C7-A3D6-FF1D5A75DB4D}"/>
               </a:ext>
             </a:extLst>
           </p:cNvPr>
@@ -4782,7 +4782,7 @@
           <p:cNvPr id="14" name="">
             <a:extLst xmlns:a="http://schemas.openxmlformats.org/drawingml/2006/main">
               <a:ext uri="{FF2B5EF4-FFF2-40B4-BE49-F238E27FC236}">
-                <a16:creationId xmlns:a16="http://schemas.microsoft.com/office/drawing/2014/main" id="{E4BC84ED-E9DD-4A3B-9439-CF4E4D88F18D}"/>
+                <a16:creationId xmlns:a16="http://schemas.microsoft.com/office/drawing/2014/main" id="{DB618586-F1AB-4826-AE41-AF4A25712E60}"/>
               </a:ext>
             </a:extLst>
           </p:cNvPr>
@@ -4844,7 +4844,7 @@
           <p:cNvPr id="15" name="">
             <a:extLst xmlns:a="http://schemas.openxmlformats.org/drawingml/2006/main">
               <a:ext uri="{FF2B5EF4-FFF2-40B4-BE49-F238E27FC236}">
-                <a16:creationId xmlns:a16="http://schemas.microsoft.com/office/drawing/2014/main" id="{D0B7D627-08CF-4163-BC63-6A5E38B99BDD}"/>
+                <a16:creationId xmlns:a16="http://schemas.microsoft.com/office/drawing/2014/main" id="{1088DAF1-315B-42E9-AB6F-7E61138BA6C7}"/>
               </a:ext>
             </a:extLst>
           </p:cNvPr>
@@ -5222,7 +5222,7 @@
           <p:cNvPr id="27" name="">
             <a:extLst xmlns:a="http://schemas.openxmlformats.org/drawingml/2006/main">
               <a:ext uri="{FF2B5EF4-FFF2-40B4-BE49-F238E27FC236}">
-                <a16:creationId xmlns:a16="http://schemas.microsoft.com/office/drawing/2014/main" id="{4EFB851A-BEFA-45E1-AB3C-F39A8D27FC91}"/>
+                <a16:creationId xmlns:a16="http://schemas.microsoft.com/office/drawing/2014/main" id="{F468F0E4-C39F-4DCC-9E46-9EAF16DA08E2}"/>
               </a:ext>
             </a:extLst>
           </p:cNvPr>
@@ -5280,7 +5280,7 @@
           <p:cNvPr id="28" name="">
             <a:extLst xmlns:a="http://schemas.openxmlformats.org/drawingml/2006/main">
               <a:ext uri="{FF2B5EF4-FFF2-40B4-BE49-F238E27FC236}">
-                <a16:creationId xmlns:a16="http://schemas.microsoft.com/office/drawing/2014/main" id="{95638EA9-674A-444C-AEA0-4ED67C5BF882}"/>
+                <a16:creationId xmlns:a16="http://schemas.microsoft.com/office/drawing/2014/main" id="{326E7A38-8722-462E-B9C6-0F643674798A}"/>
               </a:ext>
             </a:extLst>
           </p:cNvPr>
@@ -5338,7 +5338,7 @@
           <p:cNvPr id="29" name="">
             <a:extLst xmlns:a="http://schemas.openxmlformats.org/drawingml/2006/main">
               <a:ext uri="{FF2B5EF4-FFF2-40B4-BE49-F238E27FC236}">
-                <a16:creationId xmlns:a16="http://schemas.microsoft.com/office/drawing/2014/main" id="{FF573CEE-89EE-4667-B3B9-90761AFBE89B}"/>
+                <a16:creationId xmlns:a16="http://schemas.microsoft.com/office/drawing/2014/main" id="{78194DF9-CA8F-45BD-A254-7660D0B1CDBC}"/>
               </a:ext>
             </a:extLst>
           </p:cNvPr>
@@ -5394,7 +5394,7 @@
     </p:spTree>
     <p:extLst>
       <p:ext uri="{BB962C8B-B14F-4D97-AF65-F5344CB8AC3E}">
-        <p14:creationId xmlns:p14="http://schemas.microsoft.com/office/powerpoint/2010/main" val="767272122"/>
+        <p14:creationId xmlns:p14="http://schemas.microsoft.com/office/powerpoint/2010/main" val="2096057018"/>
       </p:ext>
     </p:extLst>
   </p:cSld>
@@ -5425,7 +5425,7 @@
           <p:cNvPr id="19" name="">
             <a:extLst xmlns:a="http://schemas.openxmlformats.org/drawingml/2006/main">
               <a:ext uri="{FF2B5EF4-FFF2-40B4-BE49-F238E27FC236}">
-                <a16:creationId xmlns:a16="http://schemas.microsoft.com/office/drawing/2014/main" id="{4CE57A1F-836A-44E5-9FB0-760ACF256BBF}"/>
+                <a16:creationId xmlns:a16="http://schemas.microsoft.com/office/drawing/2014/main" id="{96D20B70-BDC3-4C9E-B95A-C82856B5F73D}"/>
               </a:ext>
             </a:extLst>
           </p:cNvPr>
@@ -5483,7 +5483,7 @@
           <p:cNvPr id="2" name="">
             <a:extLst xmlns:a="http://schemas.openxmlformats.org/drawingml/2006/main">
               <a:ext uri="{FF2B5EF4-FFF2-40B4-BE49-F238E27FC236}">
-                <a16:creationId xmlns:a16="http://schemas.microsoft.com/office/drawing/2014/main" id="{EAE5DBC2-8657-4026-973B-E527BC3261CC}"/>
+                <a16:creationId xmlns:a16="http://schemas.microsoft.com/office/drawing/2014/main" id="{B3A371CD-C9DA-4659-99BD-CE1E98C6AB91}"/>
               </a:ext>
             </a:extLst>
           </p:cNvPr>
@@ -5541,7 +5541,7 @@
           <p:cNvPr id="3" name="">
             <a:extLst xmlns:a="http://schemas.openxmlformats.org/drawingml/2006/main">
               <a:ext uri="{FF2B5EF4-FFF2-40B4-BE49-F238E27FC236}">
-                <a16:creationId xmlns:a16="http://schemas.microsoft.com/office/drawing/2014/main" id="{FDB59D9E-0982-45D6-9CD6-B60976FBB65C}"/>
+                <a16:creationId xmlns:a16="http://schemas.microsoft.com/office/drawing/2014/main" id="{1646B6B5-0D79-4F17-944C-3066D3B68D3A}"/>
               </a:ext>
             </a:extLst>
           </p:cNvPr>
@@ -5599,7 +5599,7 @@
           <p:cNvPr id="4" name="">
             <a:extLst xmlns:a="http://schemas.openxmlformats.org/drawingml/2006/main">
               <a:ext uri="{FF2B5EF4-FFF2-40B4-BE49-F238E27FC236}">
-                <a16:creationId xmlns:a16="http://schemas.microsoft.com/office/drawing/2014/main" id="{0544F9A8-C29A-497B-8FD8-D0C9BD1302A0}"/>
+                <a16:creationId xmlns:a16="http://schemas.microsoft.com/office/drawing/2014/main" id="{32B04097-531C-4A41-9C67-091978B8DCFE}"/>
               </a:ext>
             </a:extLst>
           </p:cNvPr>
@@ -5632,7 +5632,7 @@
           <p:cNvPr id="5" name="">
             <a:extLst xmlns:a="http://schemas.openxmlformats.org/drawingml/2006/main">
               <a:ext uri="{FF2B5EF4-FFF2-40B4-BE49-F238E27FC236}">
-                <a16:creationId xmlns:a16="http://schemas.microsoft.com/office/drawing/2014/main" id="{D2766327-34DE-4930-8A2D-E9DAC526BE58}"/>
+                <a16:creationId xmlns:a16="http://schemas.microsoft.com/office/drawing/2014/main" id="{87680F5A-3637-45E8-BCE6-BA30CF515054}"/>
               </a:ext>
             </a:extLst>
           </p:cNvPr>
@@ -5791,7 +5791,7 @@
           <p:cNvPr id="6" name="">
             <a:extLst xmlns:a="http://schemas.openxmlformats.org/drawingml/2006/main">
               <a:ext uri="{FF2B5EF4-FFF2-40B4-BE49-F238E27FC236}">
-                <a16:creationId xmlns:a16="http://schemas.microsoft.com/office/drawing/2014/main" id="{E0058DE6-21E5-4B28-A9F7-5E65EF49C222}"/>
+                <a16:creationId xmlns:a16="http://schemas.microsoft.com/office/drawing/2014/main" id="{58763609-0FDB-4131-8074-ECDFBB3AAAEA}"/>
               </a:ext>
             </a:extLst>
           </p:cNvPr>
@@ -5978,7 +5978,7 @@
           <p:cNvPr id="7" name="">
             <a:extLst xmlns:a="http://schemas.openxmlformats.org/drawingml/2006/main">
               <a:ext uri="{FF2B5EF4-FFF2-40B4-BE49-F238E27FC236}">
-                <a16:creationId xmlns:a16="http://schemas.microsoft.com/office/drawing/2014/main" id="{F5F64B14-589C-434E-BB3E-CF56E6944C50}"/>
+                <a16:creationId xmlns:a16="http://schemas.microsoft.com/office/drawing/2014/main" id="{181DD72A-73BF-4BF8-8BEE-0359872A3222}"/>
               </a:ext>
             </a:extLst>
           </p:cNvPr>
@@ -6160,7 +6160,7 @@
           <p:cNvPr id="8" name="">
             <a:extLst xmlns:a="http://schemas.openxmlformats.org/drawingml/2006/main">
               <a:ext uri="{FF2B5EF4-FFF2-40B4-BE49-F238E27FC236}">
-                <a16:creationId xmlns:a16="http://schemas.microsoft.com/office/drawing/2014/main" id="{DCC2E170-FC9B-4CE3-92AC-624D1886EB5B}"/>
+                <a16:creationId xmlns:a16="http://schemas.microsoft.com/office/drawing/2014/main" id="{E617F3D7-07AA-4B77-B716-460DFA106B2F}"/>
               </a:ext>
             </a:extLst>
           </p:cNvPr>
@@ -6245,7 +6245,7 @@
           <p:cNvPr id="9" name="">
             <a:extLst xmlns:a="http://schemas.openxmlformats.org/drawingml/2006/main">
               <a:ext uri="{FF2B5EF4-FFF2-40B4-BE49-F238E27FC236}">
-                <a16:creationId xmlns:a16="http://schemas.microsoft.com/office/drawing/2014/main" id="{41DACDE5-2914-4EA3-B684-9BA0580E3104}"/>
+                <a16:creationId xmlns:a16="http://schemas.microsoft.com/office/drawing/2014/main" id="{C15A397C-79E6-434D-BEB7-4929FE796582}"/>
               </a:ext>
             </a:extLst>
           </p:cNvPr>
@@ -6330,7 +6330,7 @@
           <p:cNvPr id="10" name="">
             <a:extLst xmlns:a="http://schemas.openxmlformats.org/drawingml/2006/main">
               <a:ext uri="{FF2B5EF4-FFF2-40B4-BE49-F238E27FC236}">
-                <a16:creationId xmlns:a16="http://schemas.microsoft.com/office/drawing/2014/main" id="{5D00C471-8FBE-47AF-94ED-2D05E26B0125}"/>
+                <a16:creationId xmlns:a16="http://schemas.microsoft.com/office/drawing/2014/main" id="{4B345C38-0157-4D7B-BB15-ABA4DCE3F81D}"/>
               </a:ext>
             </a:extLst>
           </p:cNvPr>
@@ -6559,7 +6559,7 @@
           <p:cNvPr id="16" name="">
             <a:extLst xmlns:a="http://schemas.openxmlformats.org/drawingml/2006/main">
               <a:ext uri="{FF2B5EF4-FFF2-40B4-BE49-F238E27FC236}">
-                <a16:creationId xmlns:a16="http://schemas.microsoft.com/office/drawing/2014/main" id="{75D4DC9D-A372-458E-B26B-47F8FB36EDC0}"/>
+                <a16:creationId xmlns:a16="http://schemas.microsoft.com/office/drawing/2014/main" id="{B40926FA-99C3-4652-A908-026899F860DC}"/>
               </a:ext>
             </a:extLst>
           </p:cNvPr>
@@ -6617,7 +6617,7 @@
           <p:cNvPr id="17" name="">
             <a:extLst xmlns:a="http://schemas.openxmlformats.org/drawingml/2006/main">
               <a:ext uri="{FF2B5EF4-FFF2-40B4-BE49-F238E27FC236}">
-                <a16:creationId xmlns:a16="http://schemas.microsoft.com/office/drawing/2014/main" id="{77F80AD2-93FC-42C0-976A-C1AD294053DB}"/>
+                <a16:creationId xmlns:a16="http://schemas.microsoft.com/office/drawing/2014/main" id="{D3401EAD-0088-46D2-AF70-621F8B1DA1AD}"/>
               </a:ext>
             </a:extLst>
           </p:cNvPr>
@@ -6675,7 +6675,7 @@
           <p:cNvPr id="18" name="">
             <a:extLst xmlns:a="http://schemas.openxmlformats.org/drawingml/2006/main">
               <a:ext uri="{FF2B5EF4-FFF2-40B4-BE49-F238E27FC236}">
-                <a16:creationId xmlns:a16="http://schemas.microsoft.com/office/drawing/2014/main" id="{F4E06117-1B11-44FF-A9BA-76936C0C912F}"/>
+                <a16:creationId xmlns:a16="http://schemas.microsoft.com/office/drawing/2014/main" id="{28CB0B54-C95C-4227-81E7-2067867B3BC0}"/>
               </a:ext>
             </a:extLst>
           </p:cNvPr>
@@ -6731,7 +6731,7 @@
     </p:spTree>
     <p:extLst>
       <p:ext uri="{BB962C8B-B14F-4D97-AF65-F5344CB8AC3E}">
-        <p14:creationId xmlns:p14="http://schemas.microsoft.com/office/powerpoint/2010/main" val="1540289376"/>
+        <p14:creationId xmlns:p14="http://schemas.microsoft.com/office/powerpoint/2010/main" val="723397837"/>
       </p:ext>
     </p:extLst>
   </p:cSld>

</xml_diff>